<commit_message>
Add presentation/Praesentation_Gruppenarbeit4.pptx - Gruppenarbeit 4
</commit_message>
<xml_diff>
--- a/presentation/Praesentation_Gruppenarbeit4.pptx
+++ b/presentation/Praesentation_Gruppenarbeit4.pptx
@@ -3289,7 +3289,7 @@
                   <a:srgbClr val="4FC3F7"/>
                 </a:solidFill>
               </a:rPr>
-              <a:t>Gruppenarbeit 4 | IT-Systeme | Gruppe 3</a:t>
+              <a:t>Gruppenarbeit 4 | IT-Systeme | Gruppe 4</a:t>
             </a:r>
           </a:p>
         </p:txBody>
@@ -3656,7 +3656,7 @@
                   <a:srgbClr val="CCCCCC"/>
                 </a:solidFill>
               </a:rPr>
-              <a:t>👥  Jan  ·  Marian  ·  Mathias  ·  Marco   |   Gruppe 3</a:t>
+              <a:t>👥  Jan  ·  Marian  ·  Mathias  ·  Marco   |   Gruppe 4</a:t>
             </a:r>
           </a:p>
         </p:txBody>
@@ -3948,7 +3948,7 @@
                   <a:srgbClr val="CCCCCC"/>
                 </a:solidFill>
               </a:rPr>
-              <a:t>  Gruppe 3 | Jan · Marian · Mathias · Marco</a:t>
+              <a:t>  Gruppe 4 | Jan · Marian · Mathias · Marco</a:t>
             </a:r>
           </a:p>
         </p:txBody>
@@ -3982,7 +3982,7 @@
                   <a:srgbClr val="CCCCCC"/>
                 </a:solidFill>
               </a:rPr>
-              <a:t>172.16.30.0/24  </a:t>
+              <a:t>172.16.40.0/24  </a:t>
             </a:r>
           </a:p>
         </p:txBody>
@@ -4817,7 +4817,7 @@
                   <a:srgbClr val="CCCCCC"/>
                 </a:solidFill>
               </a:rPr>
-              <a:t>  Gruppe 3 | Jan · Marian · Mathias · Marco</a:t>
+              <a:t>  Gruppe 4 | Jan · Marian · Mathias · Marco</a:t>
             </a:r>
           </a:p>
         </p:txBody>
@@ -4851,7 +4851,7 @@
                   <a:srgbClr val="CCCCCC"/>
                 </a:solidFill>
               </a:rPr>
-              <a:t>172.16.30.0/24  </a:t>
+              <a:t>172.16.40.0/24  </a:t>
             </a:r>
           </a:p>
         </p:txBody>
@@ -4885,7 +4885,7 @@
                   <a:srgbClr val="4FC3F7"/>
                 </a:solidFill>
               </a:rPr>
-              <a:t>Netzwerkplan – Gruppe 3</a:t>
+              <a:t>Netzwerkplan – Gruppe 4</a:t>
             </a:r>
           </a:p>
         </p:txBody>
@@ -5041,7 +5041,7 @@
                   <a:srgbClr val="66BB6A"/>
                 </a:solidFill>
               </a:rPr>
-              <a:t>172.16.30.10</a:t>
+              <a:t>172.16.40.10</a:t>
             </a:r>
           </a:p>
         </p:txBody>
@@ -5075,7 +5075,7 @@
                   <a:srgbClr val="CCCCCC"/>
                 </a:solidFill>
               </a:rPr>
-              <a:t>server.gruppe3.local</a:t>
+              <a:t>server.gruppe4.local</a:t>
             </a:r>
           </a:p>
         </p:txBody>
@@ -5212,7 +5212,7 @@
                 </a:solidFill>
               </a:rPr>
               <a:t>Internes Netzwerk
-intnet-gruppe3
+intnet-gruppe4
 (VirtualBox)</a:t>
             </a:r>
           </a:p>
@@ -5326,7 +5326,7 @@
                   <a:srgbClr val="66BB6A"/>
                 </a:solidFill>
               </a:rPr>
-              <a:t>172.16.30.100</a:t>
+              <a:t>172.16.40.100</a:t>
             </a:r>
           </a:p>
         </p:txBody>
@@ -5360,7 +5360,7 @@
                   <a:srgbClr val="CCCCCC"/>
                 </a:solidFill>
               </a:rPr>
-              <a:t>client.gruppe3.local</a:t>
+              <a:t>client.gruppe4.local</a:t>
             </a:r>
           </a:p>
         </p:txBody>
@@ -5902,7 +5902,7 @@
                   <a:srgbClr val="CCCCCC"/>
                 </a:solidFill>
               </a:rPr>
-              <a:t> 172.16.30.10</a:t>
+              <a:t> 172.16.40.10</a:t>
             </a:r>
           </a:p>
         </p:txBody>
@@ -5981,7 +5981,7 @@
                   <a:srgbClr val="CCCCCC"/>
                 </a:solidFill>
               </a:rPr>
-              <a:t> server.gruppe3.local</a:t>
+              <a:t> server.gruppe4.local</a:t>
             </a:r>
           </a:p>
         </p:txBody>
@@ -6218,7 +6218,7 @@
                   <a:srgbClr val="CCCCCC"/>
                 </a:solidFill>
               </a:rPr>
-              <a:t> 172.16.30.100</a:t>
+              <a:t> 172.16.40.100</a:t>
             </a:r>
           </a:p>
         </p:txBody>
@@ -6297,7 +6297,7 @@
                   <a:srgbClr val="CCCCCC"/>
                 </a:solidFill>
               </a:rPr>
-              <a:t> client.gruppe3.local</a:t>
+              <a:t> client.gruppe4.local</a:t>
             </a:r>
           </a:p>
         </p:txBody>
@@ -6534,7 +6534,7 @@
                   <a:srgbClr val="CCCCCC"/>
                 </a:solidFill>
               </a:rPr>
-              <a:t> 172.16.30.0/24</a:t>
+              <a:t> 172.16.40.0/24</a:t>
             </a:r>
           </a:p>
         </p:txBody>
@@ -6984,7 +6984,7 @@
                   <a:srgbClr val="CCCCCC"/>
                 </a:solidFill>
               </a:rPr>
-              <a:t>  Gruppe 3 | Jan · Marian · Mathias · Marco</a:t>
+              <a:t>  Gruppe 4 | Jan · Marian · Mathias · Marco</a:t>
             </a:r>
           </a:p>
         </p:txBody>
@@ -7018,7 +7018,7 @@
                   <a:srgbClr val="CCCCCC"/>
                 </a:solidFill>
               </a:rPr>
-              <a:t>172.16.30.0/24  </a:t>
+              <a:t>172.16.40.0/24  </a:t>
             </a:r>
           </a:p>
         </p:txBody>
@@ -7751,7 +7751,7 @@
                   <a:srgbClr val="89B4FA"/>
                 </a:solidFill>
               </a:rPr>
-              <a:t>  ssh admin@172.16.30.10</a:t>
+              <a:t>  ssh admin@172.16.40.10</a:t>
             </a:r>
           </a:p>
         </p:txBody>
@@ -8439,7 +8439,7 @@
                   <a:srgbClr val="CCCCCC"/>
                 </a:solidFill>
               </a:rPr>
-              <a:t>  Gruppe 3 | Jan · Marian · Mathias · Marco</a:t>
+              <a:t>  Gruppe 4 | Jan · Marian · Mathias · Marco</a:t>
             </a:r>
           </a:p>
         </p:txBody>
@@ -8473,7 +8473,7 @@
                   <a:srgbClr val="CCCCCC"/>
                 </a:solidFill>
               </a:rPr>
-              <a:t>172.16.30.0/24  </a:t>
+              <a:t>172.16.40.0/24  </a:t>
             </a:r>
           </a:p>
         </p:txBody>
@@ -8806,7 +8806,7 @@
                   <a:srgbClr val="CCCCCC"/>
                 </a:solidFill>
               </a:rPr>
-              <a:t>Statische IP 172.16.30.10 via Netplan</a:t>
+              <a:t>Statische IP 172.16.40.10 via Netplan</a:t>
             </a:r>
           </a:p>
         </p:txBody>
@@ -8917,7 +8917,7 @@
                   <a:srgbClr val="CCCCCC"/>
                 </a:solidFill>
               </a:rPr>
-              <a:t>Hostname: server.gruppe3.local</a:t>
+              <a:t>Hostname: server.gruppe4.local</a:t>
             </a:r>
           </a:p>
         </p:txBody>
@@ -9506,7 +9506,7 @@
                   <a:srgbClr val="CCCCCC"/>
                 </a:solidFill>
               </a:rPr>
-              <a:t>Statische IP 172.16.30.100</a:t>
+              <a:t>Statische IP 172.16.40.100</a:t>
             </a:r>
           </a:p>
         </p:txBody>
@@ -10063,7 +10063,7 @@
                   <a:srgbClr val="89B4FA"/>
                 </a:solidFill>
               </a:rPr>
-              <a:t>  ssh admin@172.16.30.10</a:t>
+              <a:t>  ssh admin@172.16.40.10</a:t>
             </a:r>
           </a:p>
         </p:txBody>
@@ -10131,7 +10131,7 @@
                   <a:srgbClr val="CDD6F4"/>
                 </a:solidFill>
               </a:rPr>
-              <a:t>  http://172.16.30.10   |   http://server.gruppe3.local</a:t>
+              <a:t>  http://172.16.40.10   |   http://server.gruppe4.local</a:t>
             </a:r>
           </a:p>
         </p:txBody>
@@ -10423,7 +10423,7 @@
                   <a:srgbClr val="CCCCCC"/>
                 </a:solidFill>
               </a:rPr>
-              <a:t>  Gruppe 3 | Jan · Marian · Mathias · Marco</a:t>
+              <a:t>  Gruppe 4 | Jan · Marian · Mathias · Marco</a:t>
             </a:r>
           </a:p>
         </p:txBody>
@@ -10457,7 +10457,7 @@
                   <a:srgbClr val="CCCCCC"/>
                 </a:solidFill>
               </a:rPr>
-              <a:t>172.16.30.0/24  </a:t>
+              <a:t>172.16.40.0/24  </a:t>
             </a:r>
           </a:p>
         </p:txBody>
@@ -10647,7 +10647,7 @@
                   <a:srgbClr val="FFFFFF"/>
                 </a:solidFill>
               </a:rPr>
-              <a:t>Server-IP 172.16.30.10 konfiguriert</a:t>
+              <a:t>Server-IP 172.16.40.10 konfiguriert</a:t>
             </a:r>
           </a:p>
         </p:txBody>
@@ -10794,7 +10794,7 @@
                   <a:srgbClr val="FFFFFF"/>
                 </a:solidFill>
               </a:rPr>
-              <a:t>Client-IP 172.16.30.100 konfiguriert</a:t>
+              <a:t>Client-IP 172.16.40.100 konfiguriert</a:t>
             </a:r>
           </a:p>
         </p:txBody>
@@ -10975,7 +10975,7 @@
                   <a:srgbClr val="89B4FA"/>
                 </a:solidFill>
               </a:rPr>
-              <a:t>ping -c 4 172.16.30.10</a:t>
+              <a:t>ping -c 4 172.16.40.10</a:t>
             </a:r>
           </a:p>
         </p:txBody>
@@ -11122,7 +11122,7 @@
                   <a:srgbClr val="89B4FA"/>
                 </a:solidFill>
               </a:rPr>
-              <a:t>ssh admin@172.16.30.10</a:t>
+              <a:t>ssh admin@172.16.40.10</a:t>
             </a:r>
           </a:p>
         </p:txBody>
@@ -11416,7 +11416,7 @@
                   <a:srgbClr val="89B4FA"/>
                 </a:solidFill>
               </a:rPr>
-              <a:t>http://172.16.30.10</a:t>
+              <a:t>http://172.16.40.10</a:t>
             </a:r>
           </a:p>
         </p:txBody>
@@ -12296,7 +12296,7 @@
                   <a:srgbClr val="CCCCCC"/>
                 </a:solidFill>
               </a:rPr>
-              <a:t>  Gruppe 3 | Jan · Marian · Mathias · Marco</a:t>
+              <a:t>  Gruppe 4 | Jan · Marian · Mathias · Marco</a:t>
             </a:r>
           </a:p>
         </p:txBody>
@@ -12330,7 +12330,7 @@
                   <a:srgbClr val="CCCCCC"/>
                 </a:solidFill>
               </a:rPr>
-              <a:t>172.16.30.0/24  </a:t>
+              <a:t>172.16.40.0/24  </a:t>
             </a:r>
           </a:p>
         </p:txBody>
@@ -13355,7 +13355,7 @@
                   <a:srgbClr val="CCCCCC"/>
                 </a:solidFill>
               </a:rPr>
-              <a:t>  Gruppe 3 | Jan · Marian · Mathias · Marco</a:t>
+              <a:t>  Gruppe 4 | Jan · Marian · Mathias · Marco</a:t>
             </a:r>
           </a:p>
         </p:txBody>
@@ -13389,7 +13389,7 @@
                   <a:srgbClr val="CCCCCC"/>
                 </a:solidFill>
               </a:rPr>
-              <a:t>172.16.30.0/24  </a:t>
+              <a:t>172.16.40.0/24  </a:t>
             </a:r>
           </a:p>
         </p:txBody>
@@ -14506,7 +14506,7 @@
                   <a:srgbClr val="CCCCCC"/>
                 </a:solidFill>
               </a:rPr>
-              <a:t>http://172.16.30.10</a:t>
+              <a:t>http://172.16.40.10</a:t>
             </a:r>
           </a:p>
         </p:txBody>
@@ -14653,7 +14653,7 @@
                   <a:srgbClr val="CCCCCC"/>
                 </a:solidFill>
               </a:rPr>
-              <a:t>ssh admin@172.16.30.10</a:t>
+              <a:t>ssh admin@172.16.40.10</a:t>
             </a:r>
           </a:p>
         </p:txBody>
@@ -14981,7 +14981,7 @@
                   <a:srgbClr val="66BB6A"/>
                 </a:solidFill>
               </a:rPr>
-              <a:t>🌐  http://172.16.30.10   |   💻  ssh admin@172.16.30.10</a:t>
+              <a:t>🌐  http://172.16.40.10   |   💻  ssh admin@172.16.40.10</a:t>
             </a:r>
           </a:p>
         </p:txBody>
@@ -15015,7 +15015,7 @@
                   <a:srgbClr val="CCCCCC"/>
                 </a:solidFill>
               </a:rPr>
-              <a:t>Gruppe 3: Jan · Marian · Mathias · Marco</a:t>
+              <a:t>Gruppe 4: Jan · Marian · Mathias · Marco</a:t>
             </a:r>
           </a:p>
         </p:txBody>

</xml_diff>